<commit_message>
style: remove Made with Gamma watermark from presentation template
</commit_message>
<xml_diff>
--- a/AI-Powered-Intelligent-Security-Ecosystem.pptx
+++ b/AI-Powered-Intelligent-Security-Ecosystem.pptx
@@ -1535,32 +1535,6 @@
           <a:ln/>
         </p:spPr>
       </p:sp>
-      <p:pic>
-        <p:nvPicPr>
-          <p:cNvPr id="4" name="Image 0" descr="preencoded.png">
-            <a:hlinkClick r:id="rId2" tooltip=""/>
-          </p:cNvPr>
-          <p:cNvPicPr>
-            <a:picLocks noChangeAspect="1"/>
-          </p:cNvPicPr>
-          <p:nvPr/>
-        </p:nvPicPr>
-        <p:blipFill>
-          <a:blip r:embed="rId1"/>
-          <a:stretch>
-            <a:fillRect/>
-          </a:stretch>
-        </p:blipFill>
-        <p:spPr>
-          <a:xfrm>
-            <a:off x="8029180" y="4844491"/>
-            <a:ext cx="1071843" cy="256032"/>
-          </a:xfrm>
-          <a:prstGeom prst="rect">
-            <a:avLst/>
-          </a:prstGeom>
-        </p:spPr>
-      </p:pic>
     </p:spTree>
   </p:cSld>
   <p:clrMapOvr>

</xml_diff>